<commit_message>
update pptx to move plan after design
</commit_message>
<xml_diff>
--- a/docs/workshop-flow-diagram.pptx
+++ b/docs/workshop-flow-diagram.pptx
@@ -4518,7 +4518,7 @@
               </a:defRPr>
             </a:pPr>
             <a:r>
-              <a:t>Execution Plan</a:t>
+              <a:t>Requirements</a:t>
             </a:r>
           </a:p>
         </p:txBody>
@@ -4553,11 +4553,11 @@
               </a:defRPr>
             </a:pPr>
             <a:r>
-              <a:t>Review the plan</a:t>
+              <a:t>Review requirements</a:t>
             </a:r>
             <a:br/>
             <a:r>
-              <a:t>Approve, revise, or re-run</a:t>
+              <a:t/>
             </a:r>
           </a:p>
         </p:txBody>
@@ -4759,7 +4759,7 @@
               </a:defRPr>
             </a:pPr>
             <a:r>
-              <a:t>Requirements</a:t>
+              <a:t>Technical Design</a:t>
             </a:r>
           </a:p>
         </p:txBody>
@@ -4794,11 +4794,11 @@
               </a:defRPr>
             </a:pPr>
             <a:r>
-              <a:t>Review requirements</a:t>
+              <a:t>Review the design</a:t>
             </a:r>
             <a:br/>
             <a:r>
-              <a:t>Approve, revise, or re-run</a:t>
+              <a:t/>
             </a:r>
           </a:p>
         </p:txBody>
@@ -5000,7 +5000,7 @@
               </a:defRPr>
             </a:pPr>
             <a:r>
-              <a:t>Technical Design</a:t>
+              <a:t>Execution Plan</a:t>
             </a:r>
           </a:p>
         </p:txBody>
@@ -5035,11 +5035,11 @@
               </a:defRPr>
             </a:pPr>
             <a:r>
-              <a:t>Review the design</a:t>
+              <a:t>Review the plan</a:t>
             </a:r>
             <a:br/>
             <a:r>
-              <a:t>Approve, revise, or re-run</a:t>
+              <a:t/>
             </a:r>
           </a:p>
         </p:txBody>
@@ -7247,7 +7247,7 @@
               </a:defRPr>
             </a:pPr>
             <a:r>
-              <a:t>Execution Plan</a:t>
+              <a:t>Requirements</a:t>
             </a:r>
           </a:p>
         </p:txBody>
@@ -7282,7 +7282,7 @@
               </a:defRPr>
             </a:pPr>
             <a:r>
-              <a:t>Tech Lead</a:t>
+              <a:t>Tech Lead + PM</a:t>
             </a:r>
           </a:p>
         </p:txBody>
@@ -7404,7 +7404,7 @@
               </a:defRPr>
             </a:pPr>
             <a:r>
-              <a:t>Requirements</a:t>
+              <a:t>Technical Design</a:t>
             </a:r>
           </a:p>
         </p:txBody>
@@ -7439,7 +7439,7 @@
               </a:defRPr>
             </a:pPr>
             <a:r>
-              <a:t>Tech Lead + PM</a:t>
+              <a:t>Architect / Sr Eng</a:t>
             </a:r>
           </a:p>
         </p:txBody>
@@ -7561,7 +7561,7 @@
               </a:defRPr>
             </a:pPr>
             <a:r>
-              <a:t>Technical Design</a:t>
+              <a:t>Execution Plan</a:t>
             </a:r>
           </a:p>
         </p:txBody>
@@ -7596,7 +7596,7 @@
               </a:defRPr>
             </a:pPr>
             <a:r>
-              <a:t>Architect / Sr Eng</a:t>
+              <a:t>Tech Lead</a:t>
             </a:r>
           </a:p>
         </p:txBody>

</xml_diff>